<commit_message>
Keep the synthetic-data note to the title slide of both decks
Co-Authored-By: Claude Fable 5.1 <noreply@anthropic.com>
Claude-Session: https://claude.ai/code/session_016ymAbFop2FTD6QPnsmgJsn
</commit_message>
<xml_diff>
--- a/weibee-steel/docs/Weibee_Bid_Intelligence_Executive_Overview.pptx
+++ b/weibee-steel/docs/Weibee_Bid_Intelligence_Executive_Overview.pptx
@@ -118,18 +118,18 @@
   <p:extLst>
     <p:ext uri="{521415D9-36F7-43E2-AB2F-B90AF26B5E84}">
       <p14:sectionLst xmlns:p14="http://schemas.microsoft.com/office/powerpoint/2010/main">
-        <p14:section name="Opening" id="{46a336ab-c96b-ef68-6fd3-bd939649a738}">
+        <p14:section name="Opening" id="{9f5a5460-ca5d-ffdf-c9a4-d9017c12a752}">
           <p14:sldIdLst>
             <p14:sldId id="256"/>
             <p14:sldId id="257"/>
           </p14:sldIdLst>
         </p14:section>
-        <p14:section name="What it does" id="{74b54bbe-41a4-d8c2-e233-ebe52c48e8b9}">
+        <p14:section name="What it does" id="{4ba8a902-101b-edb0-8c6c-90dbbc5243eb}">
           <p14:sldIdLst>
             <p14:sldId id="258"/>
           </p14:sldIdLst>
         </p14:section>
-        <p14:section name="What the data says" id="{8041f50e-24c7-8818-91c1-0f9e6412b18f}">
+        <p14:section name="What the data says" id="{054af9c1-140a-2afb-fe82-4f65e7d3f724}">
           <p14:sldIdLst>
             <p14:sldId id="259"/>
             <p14:sldId id="260"/>
@@ -138,13 +138,13 @@
             <p14:sldId id="263"/>
           </p14:sldIdLst>
         </p14:section>
-        <p14:section name="The decision tool" id="{f089fde2-a094-dd90-5234-5551ffc74b86}">
+        <p14:section name="The decision tool" id="{21c7a1cf-261f-2c64-1aa9-ec725ce51a70}">
           <p14:sldIdLst>
             <p14:sldId id="264"/>
             <p14:sldId id="265"/>
           </p14:sldIdLst>
         </p14:section>
-        <p14:section name="Next steps" id="{6de5d0b6-4c53-58bb-462e-7f91ca8ead8f}">
+        <p14:section name="Next steps" id="{3788f695-af86-d2e2-1196-ecf237ea9633}">
           <p14:sldIdLst>
             <p14:sldId id="266"/>
             <p14:sldId id="267"/>
@@ -1735,7 +1735,7 @@
           <a:p>
             <a:r>
               <a:rPr lang="en-US" dirty="0"/>
-              <a:t>Open with the one-line summary: every bid we send teaches us something. Today that lesson lives in people's heads. This puts it in a table, turns it into a ranked list every Monday, and tells us how full the shop will be next year. Say clearly: the data is made up, the method is real.</a:t>
+              <a:t>Open with the one-line summary: every bid we send teaches us something. Today that lesson lives in people's heads. This puts it in a table, turns it into a ranked list every Monday, and tells us how full the shop will be next year. Say once, on this slide, that the data is made up and the method is real; it is not repeated later.</a:t>
             </a:r>
             <a:endParaRPr lang="en-US" dirty="0"/>
           </a:p>
@@ -2978,7 +2978,7 @@
                   <a:schemeClr val="accent5"/>
                 </a:solidFill>
               </a:rPr>
-              <a:t>Weibee Steel  |  Bid intelligence  |  work sample on synthetic data</a:t>
+              <a:t>Weibee Steel  |  Bid intelligence</a:t>
             </a:r>
             <a:endParaRPr lang="en-US" sz="900" dirty="0"/>
           </a:p>
@@ -3448,7 +3448,7 @@
                   <a:schemeClr val="accent6"/>
                 </a:solidFill>
               </a:rPr>
-              <a:t>Bid intelligence for Weibee Steel. A working data-and-decisions loop, shown on synthetic data.</a:t>
+              <a:t>Bid intelligence for Weibee Steel. A working data-and-decisions loop.</a:t>
             </a:r>
             <a:endParaRPr lang="en-US" sz="1800" dirty="0"/>
           </a:p>
@@ -3456,7 +3456,43 @@
       </p:sp>
       <p:sp>
         <p:nvSpPr>
-          <p:cNvPr id="4" name="byline"/>
+          <p:cNvPr id="4" name="synthetic note"/>
+          <p:cNvSpPr txBox="1"/>
+          <p:nvPr/>
+        </p:nvSpPr>
+        <p:spPr>
+          <a:xfrm>
+            <a:off x="640080" y="3657600"/>
+            <a:ext cx="7863840" cy="548640"/>
+          </a:xfrm>
+          <a:prstGeom prst="rect">
+            <a:avLst/>
+          </a:prstGeom>
+          <a:noFill/>
+          <a:ln/>
+        </p:spPr>
+        <p:txBody>
+          <a:bodyPr wrap="square" lIns="0" tIns="0" rIns="0" bIns="0" rtlCol="0" anchor="ctr"/>
+          <a:lstStyle/>
+          <a:p>
+            <a:pPr indent="0" marL="0">
+              <a:buNone/>
+            </a:pPr>
+            <a:r>
+              <a:rPr lang="en-US" sz="1200" i="1" dirty="0">
+                <a:solidFill>
+                  <a:schemeClr val="accent4"/>
+                </a:solidFill>
+              </a:rPr>
+              <a:t>Made from synthetic data. Every number in this deck comes from a generated bid history built to behave like a mid-size fabricator; none of it is Weibee Steel's data. The method runs unchanged on real history.</a:t>
+            </a:r>
+            <a:endParaRPr lang="en-US" sz="1200" dirty="0"/>
+          </a:p>
+        </p:txBody>
+      </p:sp>
+      <p:sp>
+        <p:nvSpPr>
+          <p:cNvPr id="5" name="byline"/>
           <p:cNvSpPr txBox="1"/>
           <p:nvPr/>
         </p:nvSpPr>
@@ -4738,7 +4774,7 @@
                   <a:schemeClr val="accent6"/>
                 </a:solidFill>
               </a:rPr>
-              <a:t>Report, PDF, data and code are in the repository. All data is synthetic; the method runs unchanged on real history.</a:t>
+              <a:t>Report, data and code are in the repository. The method runs unchanged on real history.</a:t>
             </a:r>
             <a:endParaRPr lang="en-US" sz="1800" dirty="0"/>
           </a:p>

</xml_diff>